<commit_message>
euBrief: čísla a jednotky ako samostatné prvky pre Canva
Co-Authored-By: Claude Opus 5.5 <noreply@anthropic.com>
Claude-Session: https://claude.ai/code/session_01FjvMrTa6JCnEmJoJzHADRh
</commit_message>
<xml_diff>
--- a/2026-10-07-eubrief-legislativny-chaos/legislativny-chaos-canva.pptx
+++ b/2026-10-07-eubrief-legislativny-chaos/legislativny-chaos-canva.pptx
@@ -1026,14 +1026,14 @@
       </p:sp>
       <p:sp>
         <p:nvSpPr>
-          <p:cNvPr id="7" name="Číslo 9-krát"/>
+          <p:cNvPr id="7" name="Číslo 9"/>
           <p:cNvSpPr txBox="1"/>
           <p:nvPr/>
         </p:nvSpPr>
         <p:spPr>
           <a:xfrm>
-            <a:off x="1397000" y="1993900"/>
-            <a:ext cx="3302000" cy="2393950"/>
+            <a:off x="1397000" y="2120900"/>
+            <a:ext cx="1206500" cy="2603500"/>
           </a:xfrm>
           <a:prstGeom prst="rect">
             <a:avLst/>
@@ -1042,10 +1042,13 @@
           <a:ln/>
         </p:spPr>
         <p:txBody>
-          <a:bodyPr wrap="square" lIns="0" tIns="0" rIns="0" bIns="0" rtlCol="0" anchor="b"/>
+          <a:bodyPr wrap="square" lIns="0" tIns="0" rIns="0" bIns="0" rtlCol="0" anchor="t"/>
           <a:lstStyle/>
           <a:p>
             <a:pPr indent="0" marL="0">
+              <a:lnSpc>
+                <a:spcPct val="120000"/>
+              </a:lnSpc>
               <a:buNone/>
             </a:pPr>
             <a:r>
@@ -1059,32 +1062,60 @@
               </a:rPr>
               <a:t>9</a:t>
             </a:r>
-            <a:pPr indent="0" marL="0">
-              <a:buNone/>
-            </a:pPr>
-            <a:r>
-              <a:rPr lang="en-US" sz="5900" b="1" dirty="0">
-                <a:solidFill>
-                  <a:srgbClr val="C4472F"/>
-                </a:solidFill>
-                <a:latin typeface="Source Sans Pro" pitchFamily="34" charset="0"/>
-                <a:ea typeface="Source Sans Pro" pitchFamily="34" charset="-122"/>
-                <a:cs typeface="Source Sans Pro" pitchFamily="34" charset="-120"/>
-              </a:rPr>
-              <a:t>-krát</a:t>
-            </a:r>
             <a:endParaRPr lang="en-US" sz="16500" dirty="0"/>
           </a:p>
         </p:txBody>
       </p:sp>
       <p:sp>
         <p:nvSpPr>
-          <p:cNvPr id="8" name="Text 9-krát"/>
+          <p:cNvPr id="8" name="Jednotka -krát"/>
           <p:cNvSpPr txBox="1"/>
           <p:nvPr/>
         </p:nvSpPr>
         <p:spPr>
           <a:xfrm>
+            <a:off x="2501900" y="3340100"/>
+            <a:ext cx="1905000" cy="952500"/>
+          </a:xfrm>
+          <a:prstGeom prst="rect">
+            <a:avLst/>
+          </a:prstGeom>
+          <a:noFill/>
+          <a:ln/>
+        </p:spPr>
+        <p:txBody>
+          <a:bodyPr wrap="square" lIns="0" tIns="0" rIns="0" bIns="0" rtlCol="0" anchor="t"/>
+          <a:lstStyle/>
+          <a:p>
+            <a:pPr indent="0" marL="0">
+              <a:lnSpc>
+                <a:spcPct val="120000"/>
+              </a:lnSpc>
+              <a:buNone/>
+            </a:pPr>
+            <a:r>
+              <a:rPr lang="en-US" sz="5940" b="1" dirty="0">
+                <a:solidFill>
+                  <a:srgbClr val="C4472F"/>
+                </a:solidFill>
+                <a:latin typeface="Source Sans Pro" pitchFamily="34" charset="0"/>
+                <a:ea typeface="Source Sans Pro" pitchFamily="34" charset="-122"/>
+                <a:cs typeface="Source Sans Pro" pitchFamily="34" charset="-120"/>
+              </a:rPr>
+              <a:t>-krát</a:t>
+            </a:r>
+            <a:endParaRPr lang="en-US" sz="5940" dirty="0"/>
+          </a:p>
+        </p:txBody>
+      </p:sp>
+      <p:sp>
+        <p:nvSpPr>
+          <p:cNvPr id="9" name="Text 9-krát"/>
+          <p:cNvSpPr txBox="1"/>
+          <p:nvPr/>
+        </p:nvSpPr>
+        <p:spPr>
+          <a:xfrm>
             <a:off x="1397000" y="4451350"/>
             <a:ext cx="3175000" cy="984250"/>
           </a:xfrm>
@@ -1155,14 +1186,14 @@
       </p:sp>
       <p:sp>
         <p:nvSpPr>
-          <p:cNvPr id="9" name="Číslo 60 %"/>
+          <p:cNvPr id="10" name="Číslo 60 %"/>
           <p:cNvSpPr txBox="1"/>
           <p:nvPr/>
         </p:nvSpPr>
         <p:spPr>
           <a:xfrm>
-            <a:off x="5181600" y="1581150"/>
-            <a:ext cx="2540000" cy="812800"/>
+            <a:off x="5181600" y="1619250"/>
+            <a:ext cx="920750" cy="965200"/>
           </a:xfrm>
           <a:prstGeom prst="rect">
             <a:avLst/>
@@ -1171,10 +1202,13 @@
           <a:ln/>
         </p:spPr>
         <p:txBody>
-          <a:bodyPr wrap="square" lIns="0" tIns="0" rIns="0" bIns="0" rtlCol="0" anchor="b"/>
+          <a:bodyPr wrap="square" lIns="0" tIns="0" rIns="0" bIns="0" rtlCol="0" anchor="t"/>
           <a:lstStyle/>
           <a:p>
             <a:pPr indent="0" marL="0">
+              <a:lnSpc>
+                <a:spcPct val="120000"/>
+              </a:lnSpc>
               <a:buNone/>
             </a:pPr>
             <a:r>
@@ -1188,32 +1222,60 @@
               </a:rPr>
               <a:t>60</a:t>
             </a:r>
-            <a:pPr indent="0" marL="0">
-              <a:buNone/>
-            </a:pPr>
-            <a:r>
-              <a:rPr lang="en-US" sz="2500" b="1" dirty="0">
-                <a:solidFill>
-                  <a:srgbClr val="1B2A41"/>
-                </a:solidFill>
-                <a:latin typeface="Source Sans Pro" pitchFamily="34" charset="0"/>
-                <a:ea typeface="Source Sans Pro" pitchFamily="34" charset="-122"/>
-                <a:cs typeface="Source Sans Pro" pitchFamily="34" charset="-120"/>
-              </a:rPr>
-              <a:t> %</a:t>
-            </a:r>
             <a:endParaRPr lang="en-US" sz="5900" dirty="0"/>
           </a:p>
         </p:txBody>
       </p:sp>
       <p:sp>
         <p:nvSpPr>
-          <p:cNvPr id="10" name="Text 60 %"/>
+          <p:cNvPr id="11" name="Jednotka 60 %"/>
           <p:cNvSpPr txBox="1"/>
           <p:nvPr/>
         </p:nvSpPr>
         <p:spPr>
           <a:xfrm>
+            <a:off x="5988050" y="2016125"/>
+            <a:ext cx="520700" cy="419100"/>
+          </a:xfrm>
+          <a:prstGeom prst="rect">
+            <a:avLst/>
+          </a:prstGeom>
+          <a:noFill/>
+          <a:ln/>
+        </p:spPr>
+        <p:txBody>
+          <a:bodyPr wrap="square" lIns="0" tIns="0" rIns="0" bIns="0" rtlCol="0" anchor="t"/>
+          <a:lstStyle/>
+          <a:p>
+            <a:pPr indent="0" marL="0">
+              <a:lnSpc>
+                <a:spcPct val="120000"/>
+              </a:lnSpc>
+              <a:buNone/>
+            </a:pPr>
+            <a:r>
+              <a:rPr lang="en-US" sz="2480" b="1" dirty="0">
+                <a:solidFill>
+                  <a:srgbClr val="1B2A41"/>
+                </a:solidFill>
+                <a:latin typeface="Source Sans Pro" pitchFamily="34" charset="0"/>
+                <a:ea typeface="Source Sans Pro" pitchFamily="34" charset="-122"/>
+                <a:cs typeface="Source Sans Pro" pitchFamily="34" charset="-120"/>
+              </a:rPr>
+              <a:t>%</a:t>
+            </a:r>
+            <a:endParaRPr lang="en-US" sz="2480" dirty="0"/>
+          </a:p>
+        </p:txBody>
+      </p:sp>
+      <p:sp>
+        <p:nvSpPr>
+          <p:cNvPr id="12" name="Text 60 %"/>
+          <p:cNvSpPr txBox="1"/>
+          <p:nvPr/>
+        </p:nvSpPr>
+        <p:spPr>
+          <a:xfrm>
             <a:off x="5181600" y="2482850"/>
             <a:ext cx="2413000" cy="889000"/>
           </a:xfrm>
@@ -1284,14 +1346,14 @@
       </p:sp>
       <p:sp>
         <p:nvSpPr>
-          <p:cNvPr id="11" name="Číslo 120-tisíc"/>
+          <p:cNvPr id="13" name="Číslo 120-tisíc"/>
           <p:cNvSpPr txBox="1"/>
           <p:nvPr/>
         </p:nvSpPr>
         <p:spPr>
           <a:xfrm>
-            <a:off x="8166100" y="1581150"/>
-            <a:ext cx="2540000" cy="812800"/>
+            <a:off x="8166100" y="1619250"/>
+            <a:ext cx="1301750" cy="965200"/>
           </a:xfrm>
           <a:prstGeom prst="rect">
             <a:avLst/>
@@ -1300,10 +1362,13 @@
           <a:ln/>
         </p:spPr>
         <p:txBody>
-          <a:bodyPr wrap="square" lIns="0" tIns="0" rIns="0" bIns="0" rtlCol="0" anchor="b"/>
+          <a:bodyPr wrap="square" lIns="0" tIns="0" rIns="0" bIns="0" rtlCol="0" anchor="t"/>
           <a:lstStyle/>
           <a:p>
             <a:pPr indent="0" marL="0">
+              <a:lnSpc>
+                <a:spcPct val="120000"/>
+              </a:lnSpc>
               <a:buNone/>
             </a:pPr>
             <a:r>
@@ -1317,32 +1382,60 @@
               </a:rPr>
               <a:t>120</a:t>
             </a:r>
-            <a:pPr indent="0" marL="0">
-              <a:buNone/>
-            </a:pPr>
-            <a:r>
-              <a:rPr lang="en-US" sz="2500" b="1" dirty="0">
-                <a:solidFill>
-                  <a:srgbClr val="1B2A41"/>
-                </a:solidFill>
-                <a:latin typeface="Source Sans Pro" pitchFamily="34" charset="0"/>
-                <a:ea typeface="Source Sans Pro" pitchFamily="34" charset="-122"/>
-                <a:cs typeface="Source Sans Pro" pitchFamily="34" charset="-120"/>
-              </a:rPr>
-              <a:t>-tisíc</a:t>
-            </a:r>
             <a:endParaRPr lang="en-US" sz="5900" dirty="0"/>
           </a:p>
         </p:txBody>
       </p:sp>
       <p:sp>
         <p:nvSpPr>
-          <p:cNvPr id="12" name="Text 120-tisíc"/>
+          <p:cNvPr id="14" name="Jednotka 120-tisíc"/>
           <p:cNvSpPr txBox="1"/>
           <p:nvPr/>
         </p:nvSpPr>
         <p:spPr>
           <a:xfrm>
+            <a:off x="9353550" y="2016125"/>
+            <a:ext cx="933450" cy="419100"/>
+          </a:xfrm>
+          <a:prstGeom prst="rect">
+            <a:avLst/>
+          </a:prstGeom>
+          <a:noFill/>
+          <a:ln/>
+        </p:spPr>
+        <p:txBody>
+          <a:bodyPr wrap="square" lIns="0" tIns="0" rIns="0" bIns="0" rtlCol="0" anchor="t"/>
+          <a:lstStyle/>
+          <a:p>
+            <a:pPr indent="0" marL="0">
+              <a:lnSpc>
+                <a:spcPct val="120000"/>
+              </a:lnSpc>
+              <a:buNone/>
+            </a:pPr>
+            <a:r>
+              <a:rPr lang="en-US" sz="2480" b="1" dirty="0">
+                <a:solidFill>
+                  <a:srgbClr val="1B2A41"/>
+                </a:solidFill>
+                <a:latin typeface="Source Sans Pro" pitchFamily="34" charset="0"/>
+                <a:ea typeface="Source Sans Pro" pitchFamily="34" charset="-122"/>
+                <a:cs typeface="Source Sans Pro" pitchFamily="34" charset="-120"/>
+              </a:rPr>
+              <a:t>-tisíc</a:t>
+            </a:r>
+            <a:endParaRPr lang="en-US" sz="2480" dirty="0"/>
+          </a:p>
+        </p:txBody>
+      </p:sp>
+      <p:sp>
+        <p:nvSpPr>
+          <p:cNvPr id="15" name="Text 120-tisíc"/>
+          <p:cNvSpPr txBox="1"/>
+          <p:nvPr/>
+        </p:nvSpPr>
+        <p:spPr>
+          <a:xfrm>
             <a:off x="8166100" y="2482850"/>
             <a:ext cx="2413000" cy="889000"/>
           </a:xfrm>
@@ -1413,14 +1506,14 @@
       </p:sp>
       <p:sp>
         <p:nvSpPr>
-          <p:cNvPr id="13" name="Číslo 3 sadzby DPH"/>
+          <p:cNvPr id="16" name="Číslo 3 sadzby DPH"/>
           <p:cNvSpPr txBox="1"/>
           <p:nvPr/>
         </p:nvSpPr>
         <p:spPr>
           <a:xfrm>
-            <a:off x="5181600" y="4044950"/>
-            <a:ext cx="2540000" cy="812800"/>
+            <a:off x="5181600" y="4083050"/>
+            <a:ext cx="533400" cy="965200"/>
           </a:xfrm>
           <a:prstGeom prst="rect">
             <a:avLst/>
@@ -1429,10 +1522,13 @@
           <a:ln/>
         </p:spPr>
         <p:txBody>
-          <a:bodyPr wrap="square" lIns="0" tIns="0" rIns="0" bIns="0" rtlCol="0" anchor="b"/>
+          <a:bodyPr wrap="square" lIns="0" tIns="0" rIns="0" bIns="0" rtlCol="0" anchor="t"/>
           <a:lstStyle/>
           <a:p>
             <a:pPr indent="0" marL="0">
+              <a:lnSpc>
+                <a:spcPct val="120000"/>
+              </a:lnSpc>
               <a:buNone/>
             </a:pPr>
             <a:r>
@@ -1452,7 +1548,7 @@
       </p:sp>
       <p:sp>
         <p:nvSpPr>
-          <p:cNvPr id="14" name="Text 3 sadzby DPH"/>
+          <p:cNvPr id="17" name="Text 3 sadzby DPH"/>
           <p:cNvSpPr txBox="1"/>
           <p:nvPr/>
         </p:nvSpPr>
@@ -1511,14 +1607,14 @@
       </p:sp>
       <p:sp>
         <p:nvSpPr>
-          <p:cNvPr id="15" name="Číslo 70 %"/>
+          <p:cNvPr id="18" name="Číslo 70 %"/>
           <p:cNvSpPr txBox="1"/>
           <p:nvPr/>
         </p:nvSpPr>
         <p:spPr>
           <a:xfrm>
-            <a:off x="8166100" y="4044950"/>
-            <a:ext cx="2540000" cy="812800"/>
+            <a:off x="8166100" y="4083050"/>
+            <a:ext cx="920750" cy="965200"/>
           </a:xfrm>
           <a:prstGeom prst="rect">
             <a:avLst/>
@@ -1527,10 +1623,13 @@
           <a:ln/>
         </p:spPr>
         <p:txBody>
-          <a:bodyPr wrap="square" lIns="0" tIns="0" rIns="0" bIns="0" rtlCol="0" anchor="b"/>
+          <a:bodyPr wrap="square" lIns="0" tIns="0" rIns="0" bIns="0" rtlCol="0" anchor="t"/>
           <a:lstStyle/>
           <a:p>
             <a:pPr indent="0" marL="0">
+              <a:lnSpc>
+                <a:spcPct val="120000"/>
+              </a:lnSpc>
               <a:buNone/>
             </a:pPr>
             <a:r>
@@ -1544,32 +1643,60 @@
               </a:rPr>
               <a:t>70</a:t>
             </a:r>
-            <a:pPr indent="0" marL="0">
-              <a:buNone/>
-            </a:pPr>
-            <a:r>
-              <a:rPr lang="en-US" sz="2500" b="1" dirty="0">
-                <a:solidFill>
-                  <a:srgbClr val="C4472F"/>
-                </a:solidFill>
-                <a:latin typeface="Source Sans Pro" pitchFamily="34" charset="0"/>
-                <a:ea typeface="Source Sans Pro" pitchFamily="34" charset="-122"/>
-                <a:cs typeface="Source Sans Pro" pitchFamily="34" charset="-120"/>
-              </a:rPr>
-              <a:t> %</a:t>
-            </a:r>
             <a:endParaRPr lang="en-US" sz="5900" dirty="0"/>
           </a:p>
         </p:txBody>
       </p:sp>
       <p:sp>
         <p:nvSpPr>
-          <p:cNvPr id="16" name="Text 70 %"/>
+          <p:cNvPr id="19" name="Jednotka 70 %"/>
           <p:cNvSpPr txBox="1"/>
           <p:nvPr/>
         </p:nvSpPr>
         <p:spPr>
           <a:xfrm>
+            <a:off x="8972550" y="4479925"/>
+            <a:ext cx="520700" cy="419100"/>
+          </a:xfrm>
+          <a:prstGeom prst="rect">
+            <a:avLst/>
+          </a:prstGeom>
+          <a:noFill/>
+          <a:ln/>
+        </p:spPr>
+        <p:txBody>
+          <a:bodyPr wrap="square" lIns="0" tIns="0" rIns="0" bIns="0" rtlCol="0" anchor="t"/>
+          <a:lstStyle/>
+          <a:p>
+            <a:pPr indent="0" marL="0">
+              <a:lnSpc>
+                <a:spcPct val="120000"/>
+              </a:lnSpc>
+              <a:buNone/>
+            </a:pPr>
+            <a:r>
+              <a:rPr lang="en-US" sz="2480" b="1" dirty="0">
+                <a:solidFill>
+                  <a:srgbClr val="C4472F"/>
+                </a:solidFill>
+                <a:latin typeface="Source Sans Pro" pitchFamily="34" charset="0"/>
+                <a:ea typeface="Source Sans Pro" pitchFamily="34" charset="-122"/>
+                <a:cs typeface="Source Sans Pro" pitchFamily="34" charset="-120"/>
+              </a:rPr>
+              <a:t>%</a:t>
+            </a:r>
+            <a:endParaRPr lang="en-US" sz="2480" dirty="0"/>
+          </a:p>
+        </p:txBody>
+      </p:sp>
+      <p:sp>
+        <p:nvSpPr>
+          <p:cNvPr id="20" name="Text 70 %"/>
+          <p:cNvSpPr txBox="1"/>
+          <p:nvPr/>
+        </p:nvSpPr>
+        <p:spPr>
+          <a:xfrm>
             <a:off x="8166100" y="4946650"/>
             <a:ext cx="2413000" cy="889000"/>
           </a:xfrm>
@@ -1640,7 +1767,7 @@
       </p:sp>
       <p:sp>
         <p:nvSpPr>
-          <p:cNvPr id="17" name="Pätička – linka"/>
+          <p:cNvPr id="21" name="Pätička – linka"/>
           <p:cNvSpPr/>
           <p:nvPr/>
         </p:nvSpPr>
@@ -1663,7 +1790,7 @@
       </p:sp>
       <p:sp>
         <p:nvSpPr>
-          <p:cNvPr id="18" name="Pätička – zdroje"/>
+          <p:cNvPr id="22" name="Pätička – zdroje"/>
           <p:cNvSpPr txBox="1"/>
           <p:nvPr/>
         </p:nvSpPr>
@@ -1702,7 +1829,7 @@
       </p:sp>
       <p:sp>
         <p:nvSpPr>
-          <p:cNvPr id="19" name="Pätička – podpis"/>
+          <p:cNvPr id="23" name="Pätička – podpis"/>
           <p:cNvSpPr txBox="1"/>
           <p:nvPr/>
         </p:nvSpPr>

</xml_diff>